<commit_message>
docs: add comprehensive training overview and refactor install skill
Separated tool installation from plugin installation concerns. Install skill
now focuses on OS-specific prerequisites (Node.js, Rust, uv), with plugins
delegated to /install_plugins. Added detailed README explaining the four-part
training progression and core concepts.

Generated with [Claude Code](https://claude.com/claude-code)

Co-Authored-By: Claude Opus 4.5 <noreply@anthropic.com>
</commit_message>
<xml_diff>
--- a/claude-code-advanced-training.pptx
+++ b/claude-code-advanced-training.pptx
@@ -52,6 +52,8 @@
     <p:sldId id="300" r:id="rId51"/>
     <p:sldId id="301" r:id="rId52"/>
     <p:sldId id="302" r:id="rId53"/>
+    <p:sldId id="303" r:id="rId54"/>
+    <p:sldId id="304" r:id="rId55"/>
   </p:sldIdLst>
   <p:sldSz cx="12191695" cy="6858000" type="screen4x3"/>
   <p:notesSz cx="6858000" cy="9144000"/>
@@ -3436,7 +3438,7 @@
               </a:defRPr>
             </a:pPr>
             <a:r>
-              <a:t>Key Commands in This Repo</a:t>
+              <a:t>Training Repo: Commands &amp; Skills</a:t>
             </a:r>
           </a:p>
         </p:txBody>
@@ -3492,8 +3494,8 @@
         </p:nvSpPr>
         <p:spPr>
           <a:xfrm>
-            <a:off x="731520" y="1280160"/>
-            <a:ext cx="5029200" cy="4114800"/>
+            <a:off x="731520" y="1188720"/>
+            <a:ext cx="5029200" cy="457200"/>
           </a:xfrm>
           <a:prstGeom prst="rect">
             <a:avLst/>
@@ -3506,103 +3508,16 @@
           </a:bodyPr>
           <a:lstStyle/>
           <a:p>
-            <a:pPr>
-              <a:spcAft>
-                <a:spcPts val="1800"/>
-              </a:spcAft>
-            </a:pPr>
-            <a:r>
-              <a:rPr sz="1700" b="1">
+            <a:pPr algn="l">
+              <a:defRPr sz="2000" b="1">
                 <a:solidFill>
                   <a:srgbClr val="74C7EC"/>
                 </a:solidFill>
                 <a:latin typeface="JetBrains Mono"/>
-              </a:rPr>
-              <a:t>/feature</a:t>
-            </a:r>
-            <a:r>
-              <a:rPr sz="1700">
-                <a:solidFill>
-                  <a:srgbClr val="CDD6F4"/>
-                </a:solidFill>
-                <a:latin typeface="JetBrains Mono"/>
-              </a:rPr>
-              <a:t>  Plan a new feature from requirements</a:t>
-            </a:r>
-          </a:p>
-          <a:p>
-            <a:pPr>
-              <a:spcAft>
-                <a:spcPts val="1800"/>
-              </a:spcAft>
-            </a:pPr>
-            <a:r>
-              <a:rPr sz="1700" b="1">
-                <a:solidFill>
-                  <a:srgbClr val="74C7EC"/>
-                </a:solidFill>
-                <a:latin typeface="JetBrains Mono"/>
-              </a:rPr>
-              <a:t>/implement</a:t>
-            </a:r>
-            <a:r>
-              <a:rPr sz="1700">
-                <a:solidFill>
-                  <a:srgbClr val="CDD6F4"/>
-                </a:solidFill>
-                <a:latin typeface="JetBrains Mono"/>
-              </a:rPr>
-              <a:t>  Execute an implementation plan</a:t>
-            </a:r>
-          </a:p>
-          <a:p>
-            <a:pPr>
-              <a:spcAft>
-                <a:spcPts val="1800"/>
-              </a:spcAft>
-            </a:pPr>
-            <a:r>
-              <a:rPr sz="1700" b="1">
-                <a:solidFill>
-                  <a:srgbClr val="74C7EC"/>
-                </a:solidFill>
-                <a:latin typeface="JetBrains Mono"/>
-              </a:rPr>
-              <a:t>/test</a:t>
-            </a:r>
-            <a:r>
-              <a:rPr sz="1700">
-                <a:solidFill>
-                  <a:srgbClr val="CDD6F4"/>
-                </a:solidFill>
-                <a:latin typeface="JetBrains Mono"/>
-              </a:rPr>
-              <a:t>  Run full validation test suite</a:t>
-            </a:r>
-          </a:p>
-          <a:p>
-            <a:pPr>
-              <a:spcAft>
-                <a:spcPts val="1800"/>
-              </a:spcAft>
-            </a:pPr>
-            <a:r>
-              <a:rPr sz="1700" b="1">
-                <a:solidFill>
-                  <a:srgbClr val="74C7EC"/>
-                </a:solidFill>
-                <a:latin typeface="JetBrains Mono"/>
-              </a:rPr>
-              <a:t>/install</a:t>
-            </a:r>
-            <a:r>
-              <a:rPr sz="1700">
-                <a:solidFill>
-                  <a:srgbClr val="CDD6F4"/>
-                </a:solidFill>
-                <a:latin typeface="JetBrains Mono"/>
-              </a:rPr>
-              <a:t>  Install all required tools for development</a:t>
+              </a:defRPr>
+            </a:pPr>
+            <a:r>
+              <a:t>Commands</a:t>
             </a:r>
           </a:p>
         </p:txBody>
@@ -3615,8 +3530,8 @@
         </p:nvSpPr>
         <p:spPr>
           <a:xfrm>
-            <a:off x="6217920" y="1280160"/>
-            <a:ext cx="5029200" cy="4114800"/>
+            <a:off x="731520" y="1828800"/>
+            <a:ext cx="5029200" cy="2743200"/>
           </a:xfrm>
           <a:prstGeom prst="rect">
             <a:avLst/>
@@ -3641,6 +3556,81 @@
                 </a:solidFill>
                 <a:latin typeface="JetBrains Mono"/>
               </a:rPr>
+              <a:t>/prime</a:t>
+            </a:r>
+            <a:r>
+              <a:rPr sz="1700">
+                <a:solidFill>
+                  <a:srgbClr val="CDD6F4"/>
+                </a:solidFill>
+                <a:latin typeface="JetBrains Mono"/>
+              </a:rPr>
+              <a:t>  Read codebase structure and summarize understanding</a:t>
+            </a:r>
+          </a:p>
+          <a:p>
+            <a:pPr>
+              <a:spcAft>
+                <a:spcPts val="1800"/>
+              </a:spcAft>
+            </a:pPr>
+            <a:r>
+              <a:rPr sz="1700" b="1">
+                <a:solidFill>
+                  <a:srgbClr val="74C7EC"/>
+                </a:solidFill>
+                <a:latin typeface="JetBrains Mono"/>
+              </a:rPr>
+              <a:t>/spec-interview</a:t>
+            </a:r>
+            <a:r>
+              <a:rPr sz="1700">
+                <a:solidFill>
+                  <a:srgbClr val="CDD6F4"/>
+                </a:solidFill>
+                <a:latin typeface="JetBrains Mono"/>
+              </a:rPr>
+              <a:t>  In-depth interview to refine a spec</a:t>
+            </a:r>
+          </a:p>
+          <a:p>
+            <a:pPr>
+              <a:spcAft>
+                <a:spcPts val="1800"/>
+              </a:spcAft>
+            </a:pPr>
+            <a:r>
+              <a:rPr sz="1700" b="1">
+                <a:solidFill>
+                  <a:srgbClr val="74C7EC"/>
+                </a:solidFill>
+                <a:latin typeface="JetBrains Mono"/>
+              </a:rPr>
+              <a:t>/feature</a:t>
+            </a:r>
+            <a:r>
+              <a:rPr sz="1700">
+                <a:solidFill>
+                  <a:srgbClr val="CDD6F4"/>
+                </a:solidFill>
+                <a:latin typeface="JetBrains Mono"/>
+              </a:rPr>
+              <a:t>  Plan a new feature with structured spec format</a:t>
+            </a:r>
+          </a:p>
+          <a:p>
+            <a:pPr>
+              <a:spcAft>
+                <a:spcPts val="1800"/>
+              </a:spcAft>
+            </a:pPr>
+            <a:r>
+              <a:rPr sz="1700" b="1">
+                <a:solidFill>
+                  <a:srgbClr val="74C7EC"/>
+                </a:solidFill>
+                <a:latin typeface="JetBrains Mono"/>
+              </a:rPr>
               <a:t>/review</a:t>
             </a:r>
             <a:r>
@@ -3650,57 +3640,7 @@
                 </a:solidFill>
                 <a:latin typeface="JetBrains Mono"/>
               </a:rPr>
-              <a:t>  Review code against the spec</a:t>
-            </a:r>
-          </a:p>
-          <a:p>
-            <a:pPr>
-              <a:spcAft>
-                <a:spcPts val="1800"/>
-              </a:spcAft>
-            </a:pPr>
-            <a:r>
-              <a:rPr sz="1700" b="1">
-                <a:solidFill>
-                  <a:srgbClr val="74C7EC"/>
-                </a:solidFill>
-                <a:latin typeface="JetBrains Mono"/>
-              </a:rPr>
-              <a:t>/document</a:t>
-            </a:r>
-            <a:r>
-              <a:rPr sz="1700">
-                <a:solidFill>
-                  <a:srgbClr val="CDD6F4"/>
-                </a:solidFill>
-                <a:latin typeface="JetBrains Mono"/>
-              </a:rPr>
-              <a:t>  Generate markdown documentation</a:t>
-            </a:r>
-          </a:p>
-          <a:p>
-            <a:pPr>
-              <a:spcAft>
-                <a:spcPts val="1800"/>
-              </a:spcAft>
-            </a:pPr>
-            <a:r>
-              <a:rPr sz="1700" b="1">
-                <a:solidFill>
-                  <a:srgbClr val="74C7EC"/>
-                </a:solidFill>
-                <a:latin typeface="JetBrains Mono"/>
-              </a:rPr>
-              <a:t>/commit</a:t>
-            </a:r>
-            <a:r>
-              <a:rPr sz="1700">
-                <a:solidFill>
-                  <a:srgbClr val="CDD6F4"/>
-                </a:solidFill>
-                <a:latin typeface="JetBrains Mono"/>
-              </a:rPr>
-              <a:t>  Create semantic git commits</a:t>
+              <a:t>  Review work against spec, capture screenshots</a:t>
             </a:r>
           </a:p>
         </p:txBody>
@@ -3713,8 +3653,8 @@
         </p:nvSpPr>
         <p:spPr>
           <a:xfrm>
-            <a:off x="731520" y="5029200"/>
-            <a:ext cx="10058400" cy="548640"/>
+            <a:off x="6400800" y="1188720"/>
+            <a:ext cx="5029200" cy="457200"/>
           </a:xfrm>
           <a:prstGeom prst="rect">
             <a:avLst/>
@@ -3728,6 +3668,183 @@
           <a:lstStyle/>
           <a:p>
             <a:pPr algn="l">
+              <a:defRPr sz="2000" b="1">
+                <a:solidFill>
+                  <a:srgbClr val="94E2D5"/>
+                </a:solidFill>
+                <a:latin typeface="JetBrains Mono"/>
+              </a:defRPr>
+            </a:pPr>
+            <a:r>
+              <a:t>Skills</a:t>
+            </a:r>
+          </a:p>
+        </p:txBody>
+      </p:sp>
+      <p:sp>
+        <p:nvSpPr>
+          <p:cNvPr id="8" name="TextBox 7"/>
+          <p:cNvSpPr txBox="1"/>
+          <p:nvPr/>
+        </p:nvSpPr>
+        <p:spPr>
+          <a:xfrm>
+            <a:off x="6400800" y="1828800"/>
+            <a:ext cx="5029200" cy="2743200"/>
+          </a:xfrm>
+          <a:prstGeom prst="rect">
+            <a:avLst/>
+          </a:prstGeom>
+          <a:noFill/>
+        </p:spPr>
+        <p:txBody>
+          <a:bodyPr wrap="square">
+            <a:spAutoFit/>
+          </a:bodyPr>
+          <a:lstStyle/>
+          <a:p>
+            <a:pPr>
+              <a:spcAft>
+                <a:spcPts val="1400"/>
+              </a:spcAft>
+            </a:pPr>
+            <a:r>
+              <a:rPr sz="1700" b="1">
+                <a:solidFill>
+                  <a:srgbClr val="94E2D5"/>
+                </a:solidFill>
+                <a:latin typeface="JetBrains Mono"/>
+              </a:rPr>
+              <a:t>/install</a:t>
+            </a:r>
+            <a:r>
+              <a:rPr sz="1700">
+                <a:solidFill>
+                  <a:srgbClr val="CDD6F4"/>
+                </a:solidFill>
+                <a:latin typeface="JetBrains Mono"/>
+              </a:rPr>
+              <a:t>  Auto-detect OS, install Node.js, Rust, uv, Git</a:t>
+            </a:r>
+          </a:p>
+          <a:p>
+            <a:pPr>
+              <a:spcAft>
+                <a:spcPts val="1400"/>
+              </a:spcAft>
+            </a:pPr>
+            <a:r>
+              <a:rPr sz="1700" b="1">
+                <a:solidFill>
+                  <a:srgbClr val="94E2D5"/>
+                </a:solidFill>
+                <a:latin typeface="JetBrains Mono"/>
+              </a:rPr>
+              <a:t/>
+            </a:r>
+            <a:r>
+              <a:rPr sz="1700">
+                <a:solidFill>
+                  <a:srgbClr val="CDD6F4"/>
+                </a:solidFill>
+                <a:latin typeface="JetBrains Mono"/>
+              </a:rPr>
+              <a:t>  Install Claude Code plugins (superpowers, skill-creator)</a:t>
+            </a:r>
+          </a:p>
+          <a:p>
+            <a:pPr>
+              <a:spcAft>
+                <a:spcPts val="1400"/>
+              </a:spcAft>
+            </a:pPr>
+            <a:r>
+              <a:rPr sz="1700" b="1">
+                <a:solidFill>
+                  <a:srgbClr val="94E2D5"/>
+                </a:solidFill>
+                <a:latin typeface="JetBrains Mono"/>
+              </a:rPr>
+              <a:t/>
+            </a:r>
+            <a:r>
+              <a:rPr sz="1700">
+                <a:solidFill>
+                  <a:srgbClr val="CDD6F4"/>
+                </a:solidFill>
+                <a:latin typeface="JetBrains Mono"/>
+              </a:rPr>
+              <a:t>  Show manual steps for anything that failed</a:t>
+            </a:r>
+          </a:p>
+        </p:txBody>
+      </p:sp>
+      <p:sp>
+        <p:nvSpPr>
+          <p:cNvPr id="9" name="Rectangle 8"/>
+          <p:cNvSpPr/>
+          <p:nvPr/>
+        </p:nvSpPr>
+        <p:spPr>
+          <a:xfrm>
+            <a:off x="5943600" y="1188720"/>
+            <a:ext cx="36576" cy="4114800"/>
+          </a:xfrm>
+          <a:prstGeom prst="rect">
+            <a:avLst/>
+          </a:prstGeom>
+          <a:solidFill>
+            <a:srgbClr val="45475A"/>
+          </a:solidFill>
+          <a:ln>
+            <a:noFill/>
+          </a:ln>
+        </p:spPr>
+        <p:style>
+          <a:lnRef idx="1">
+            <a:schemeClr val="accent1"/>
+          </a:lnRef>
+          <a:fillRef idx="3">
+            <a:schemeClr val="accent1"/>
+          </a:fillRef>
+          <a:effectRef idx="2">
+            <a:schemeClr val="accent1"/>
+          </a:effectRef>
+          <a:fontRef idx="minor">
+            <a:schemeClr val="lt1"/>
+          </a:fontRef>
+        </p:style>
+        <p:txBody>
+          <a:bodyPr rtlCol="0" anchor="ctr"/>
+          <a:lstStyle/>
+          <a:p>
+            <a:pPr algn="ctr"/>
+          </a:p>
+        </p:txBody>
+      </p:sp>
+      <p:sp>
+        <p:nvSpPr>
+          <p:cNvPr id="10" name="TextBox 9"/>
+          <p:cNvSpPr txBox="1"/>
+          <p:nvPr/>
+        </p:nvSpPr>
+        <p:spPr>
+          <a:xfrm>
+            <a:off x="731520" y="5029200"/>
+            <a:ext cx="10058400" cy="548640"/>
+          </a:xfrm>
+          <a:prstGeom prst="rect">
+            <a:avLst/>
+          </a:prstGeom>
+          <a:noFill/>
+        </p:spPr>
+        <p:txBody>
+          <a:bodyPr wrap="square">
+            <a:spAutoFit/>
+          </a:bodyPr>
+          <a:lstStyle/>
+          <a:p>
+            <a:pPr algn="l">
               <a:defRPr sz="1600" b="0">
                 <a:solidFill>
                   <a:srgbClr val="9399B2"/>
@@ -3736,7 +3853,7 @@
               </a:defRPr>
             </a:pPr>
             <a:r>
-              <a:t>27 commands total — covering the entire SDLC pipeline</a:t>
+              <a:t>Stored in .claude/commands/ and .claude/skills/ — shipped with the training repo</a:t>
             </a:r>
           </a:p>
         </p:txBody>
@@ -15475,7 +15592,7 @@
               </a:defRPr>
             </a:pPr>
             <a:r>
-              <a:t>Tic-Tac-Toe — built four different ways:</a:t>
+              <a:t>Tic-Tac-Toe — built two different ways:</a:t>
             </a:r>
           </a:p>
         </p:txBody>
@@ -15564,7 +15681,7 @@
                 </a:solidFill>
                 <a:latin typeface="JetBrains Mono"/>
               </a:rPr>
-              <a:t>3. </a:t>
+              <a:t>   </a:t>
             </a:r>
             <a:r>
               <a:rPr sz="2000">
@@ -15573,32 +15690,7 @@
                 </a:solidFill>
                 <a:latin typeface="JetBrains Mono"/>
               </a:rPr>
-              <a:t>Rust backend + TypeScript frontend via slash commands</a:t>
-            </a:r>
-          </a:p>
-          <a:p>
-            <a:pPr>
-              <a:spcAft>
-                <a:spcPts val="2000"/>
-              </a:spcAft>
-            </a:pPr>
-            <a:r>
-              <a:rPr sz="2000" b="1">
-                <a:solidFill>
-                  <a:srgbClr val="A6E3A1"/>
-                </a:solidFill>
-                <a:latin typeface="JetBrains Mono"/>
-              </a:rPr>
-              <a:t>4. </a:t>
-            </a:r>
-            <a:r>
-              <a:rPr sz="2000">
-                <a:solidFill>
-                  <a:srgbClr val="CDD6F4"/>
-                </a:solidFill>
-                <a:latin typeface="JetBrains Mono"/>
-              </a:rPr>
-              <a:t>Full ADW automation pipeline (isolated worktrees)</a:t>
+              <a:t>Then I show you how the Full ADW automation pipeline works</a:t>
             </a:r>
           </a:p>
         </p:txBody>
@@ -17523,6 +17615,31 @@
                 </a:solidFill>
                 <a:latin typeface="JetBrains Mono"/>
               </a:rPr>
+              <a:t>Training repo: explore .claude/commands/ and .claude/skills/</a:t>
+            </a:r>
+          </a:p>
+          <a:p>
+            <a:pPr>
+              <a:spcAft>
+                <a:spcPts val="1800"/>
+              </a:spcAft>
+            </a:pPr>
+            <a:r>
+              <a:rPr sz="1800" b="1">
+                <a:solidFill>
+                  <a:srgbClr val="F2CDCD"/>
+                </a:solidFill>
+                <a:latin typeface="JetBrains Mono"/>
+              </a:rPr>
+              <a:t>• </a:t>
+            </a:r>
+            <a:r>
+              <a:rPr sz="1800">
+                <a:solidFill>
+                  <a:srgbClr val="CDD6F4"/>
+                </a:solidFill>
+                <a:latin typeface="JetBrains Mono"/>
+              </a:rPr>
               <a:t>Claude Code docs: docs.anthropic.com</a:t>
             </a:r>
           </a:p>
@@ -17548,7 +17665,7 @@
                 </a:solidFill>
                 <a:latin typeface="JetBrains Mono"/>
               </a:rPr>
-              <a:t>This repo: explore .claude/commands/ for all 27 commands</a:t>
+              <a:t>Tactical Agentic Coding: agenticengineer.com/tactical-agentic-coding</a:t>
             </a:r>
           </a:p>
           <a:p>
@@ -17564,7 +17681,7 @@
                 </a:solidFill>
                 <a:latin typeface="JetBrains Mono"/>
               </a:rPr>
-              <a:t>• </a:t>
+              <a:t>  </a:t>
             </a:r>
             <a:r>
               <a:rPr sz="1800">
@@ -17573,7 +17690,7 @@
                 </a:solidFill>
                 <a:latin typeface="JetBrains Mono"/>
               </a:rPr>
-              <a:t>ADW docs: adws/README.md</a:t>
+              <a:t>Practical patterns for working effectively with AI coding agents</a:t>
             </a:r>
           </a:p>
           <a:p>
@@ -17612,6 +17729,1082 @@
 </file>
 
 <file path=ppt/slides/slide47.xml><?xml version="1.0" encoding="utf-8"?>
+<p:sld xmlns:a="http://schemas.openxmlformats.org/drawingml/2006/main" xmlns:p="http://schemas.openxmlformats.org/presentationml/2006/main" xmlns:r="http://schemas.openxmlformats.org/officeDocument/2006/relationships">
+  <p:cSld>
+    <p:bg>
+      <p:bgPr>
+        <a:solidFill>
+          <a:srgbClr val="1E1E2E"/>
+        </a:solidFill>
+        <a:effectLst/>
+      </p:bgPr>
+    </p:bg>
+    <p:spTree>
+      <p:nvGrpSpPr>
+        <p:cNvPr id="1" name=""/>
+        <p:cNvGrpSpPr/>
+        <p:nvPr/>
+      </p:nvGrpSpPr>
+      <p:grpSpPr/>
+      <p:sp>
+        <p:nvSpPr>
+          <p:cNvPr id="2" name="Rectangle 1"/>
+          <p:cNvSpPr/>
+          <p:nvPr/>
+        </p:nvSpPr>
+        <p:spPr>
+          <a:xfrm>
+            <a:off x="0" y="0"/>
+            <a:ext cx="73152" cy="6858000"/>
+          </a:xfrm>
+          <a:prstGeom prst="rect">
+            <a:avLst/>
+          </a:prstGeom>
+          <a:solidFill>
+            <a:srgbClr val="F2CDCD"/>
+          </a:solidFill>
+          <a:ln>
+            <a:noFill/>
+          </a:ln>
+        </p:spPr>
+        <p:style>
+          <a:lnRef idx="1">
+            <a:schemeClr val="accent1"/>
+          </a:lnRef>
+          <a:fillRef idx="3">
+            <a:schemeClr val="accent1"/>
+          </a:fillRef>
+          <a:effectRef idx="2">
+            <a:schemeClr val="accent1"/>
+          </a:effectRef>
+          <a:fontRef idx="minor">
+            <a:schemeClr val="lt1"/>
+          </a:fontRef>
+        </p:style>
+        <p:txBody>
+          <a:bodyPr rtlCol="0" anchor="ctr"/>
+          <a:lstStyle/>
+          <a:p>
+            <a:pPr algn="ctr"/>
+          </a:p>
+        </p:txBody>
+      </p:sp>
+      <p:sp>
+        <p:nvSpPr>
+          <p:cNvPr id="3" name="TextBox 2"/>
+          <p:cNvSpPr txBox="1"/>
+          <p:nvPr/>
+        </p:nvSpPr>
+        <p:spPr>
+          <a:xfrm>
+            <a:off x="548640" y="274320"/>
+            <a:ext cx="9144000" cy="640080"/>
+          </a:xfrm>
+          <a:prstGeom prst="rect">
+            <a:avLst/>
+          </a:prstGeom>
+          <a:noFill/>
+        </p:spPr>
+        <p:txBody>
+          <a:bodyPr wrap="square">
+            <a:spAutoFit/>
+          </a:bodyPr>
+          <a:lstStyle/>
+          <a:p>
+            <a:pPr algn="l">
+              <a:defRPr sz="2800" b="1">
+                <a:solidFill>
+                  <a:srgbClr val="CDD6F4"/>
+                </a:solidFill>
+                <a:latin typeface="JetBrains Mono"/>
+              </a:defRPr>
+            </a:pPr>
+            <a:r>
+              <a:t>Recommended Tools &amp; Plugins</a:t>
+            </a:r>
+          </a:p>
+        </p:txBody>
+      </p:sp>
+      <p:sp>
+        <p:nvSpPr>
+          <p:cNvPr id="4" name="Rectangle 3"/>
+          <p:cNvSpPr/>
+          <p:nvPr/>
+        </p:nvSpPr>
+        <p:spPr>
+          <a:xfrm>
+            <a:off x="548640" y="960120"/>
+            <a:ext cx="2743200" cy="36576"/>
+          </a:xfrm>
+          <a:prstGeom prst="rect">
+            <a:avLst/>
+          </a:prstGeom>
+          <a:solidFill>
+            <a:srgbClr val="F2CDCD"/>
+          </a:solidFill>
+          <a:ln>
+            <a:noFill/>
+          </a:ln>
+        </p:spPr>
+        <p:style>
+          <a:lnRef idx="1">
+            <a:schemeClr val="accent1"/>
+          </a:lnRef>
+          <a:fillRef idx="3">
+            <a:schemeClr val="accent1"/>
+          </a:fillRef>
+          <a:effectRef idx="2">
+            <a:schemeClr val="accent1"/>
+          </a:effectRef>
+          <a:fontRef idx="minor">
+            <a:schemeClr val="lt1"/>
+          </a:fontRef>
+        </p:style>
+        <p:txBody>
+          <a:bodyPr rtlCol="0" anchor="ctr"/>
+          <a:lstStyle/>
+          <a:p>
+            <a:pPr algn="ctr"/>
+          </a:p>
+        </p:txBody>
+      </p:sp>
+      <p:sp>
+        <p:nvSpPr>
+          <p:cNvPr id="5" name="TextBox 4"/>
+          <p:cNvSpPr txBox="1"/>
+          <p:nvPr/>
+        </p:nvSpPr>
+        <p:spPr>
+          <a:xfrm>
+            <a:off x="731520" y="1188720"/>
+            <a:ext cx="10058400" cy="457200"/>
+          </a:xfrm>
+          <a:prstGeom prst="rect">
+            <a:avLst/>
+          </a:prstGeom>
+          <a:noFill/>
+        </p:spPr>
+        <p:txBody>
+          <a:bodyPr wrap="square">
+            <a:spAutoFit/>
+          </a:bodyPr>
+          <a:lstStyle/>
+          <a:p>
+            <a:pPr algn="l">
+              <a:defRPr sz="2200" b="1">
+                <a:solidFill>
+                  <a:srgbClr val="94E2D5"/>
+                </a:solidFill>
+                <a:latin typeface="JetBrains Mono"/>
+              </a:defRPr>
+            </a:pPr>
+            <a:r>
+              <a:t>CC Status Line</a:t>
+            </a:r>
+          </a:p>
+        </p:txBody>
+      </p:sp>
+      <p:sp>
+        <p:nvSpPr>
+          <p:cNvPr id="6" name="TextBox 5"/>
+          <p:cNvSpPr txBox="1"/>
+          <p:nvPr/>
+        </p:nvSpPr>
+        <p:spPr>
+          <a:xfrm>
+            <a:off x="731520" y="1737360"/>
+            <a:ext cx="10058400" cy="914400"/>
+          </a:xfrm>
+          <a:prstGeom prst="rect">
+            <a:avLst/>
+          </a:prstGeom>
+          <a:noFill/>
+        </p:spPr>
+        <p:txBody>
+          <a:bodyPr wrap="square">
+            <a:spAutoFit/>
+          </a:bodyPr>
+          <a:lstStyle/>
+          <a:p>
+            <a:pPr>
+              <a:spcAft>
+                <a:spcPts val="600"/>
+              </a:spcAft>
+            </a:pPr>
+            <a:r>
+              <a:rPr sz="1500" b="1">
+                <a:solidFill>
+                  <a:srgbClr val="94E2D5"/>
+                </a:solidFill>
+                <a:latin typeface="JetBrains Mono"/>
+              </a:rPr>
+              <a:t>• </a:t>
+            </a:r>
+            <a:r>
+              <a:rPr sz="1500">
+                <a:solidFill>
+                  <a:srgbClr val="CDD6F4"/>
+                </a:solidFill>
+                <a:latin typeface="JetBrains Mono"/>
+              </a:rPr>
+              <a:t>Shows model, context %, session cost, clock, git branch</a:t>
+            </a:r>
+          </a:p>
+          <a:p>
+            <a:pPr>
+              <a:spcAft>
+                <a:spcPts val="600"/>
+              </a:spcAft>
+            </a:pPr>
+            <a:r>
+              <a:rPr sz="1500" b="1">
+                <a:solidFill>
+                  <a:srgbClr val="94E2D5"/>
+                </a:solidFill>
+                <a:latin typeface="JetBrains Mono"/>
+              </a:rPr>
+              <a:t>• </a:t>
+            </a:r>
+            <a:r>
+              <a:rPr sz="1500">
+                <a:solidFill>
+                  <a:srgbClr val="CDD6F4"/>
+                </a:solidFill>
+                <a:latin typeface="JetBrains Mono"/>
+              </a:rPr>
+              <a:t>Context % is critical — past ~50% Claude starts forgetting</a:t>
+            </a:r>
+          </a:p>
+        </p:txBody>
+      </p:sp>
+      <p:sp>
+        <p:nvSpPr>
+          <p:cNvPr id="7" name="Rounded Rectangle 6"/>
+          <p:cNvSpPr/>
+          <p:nvPr/>
+        </p:nvSpPr>
+        <p:spPr>
+          <a:xfrm>
+            <a:off x="731520" y="2743200"/>
+            <a:ext cx="4572000" cy="548640"/>
+          </a:xfrm>
+          <a:prstGeom prst="roundRect">
+            <a:avLst/>
+          </a:prstGeom>
+          <a:solidFill>
+            <a:srgbClr val="181825"/>
+          </a:solidFill>
+          <a:ln>
+            <a:noFill/>
+          </a:ln>
+          <a:effectLst/>
+        </p:spPr>
+        <p:style>
+          <a:lnRef idx="1">
+            <a:schemeClr val="accent1"/>
+          </a:lnRef>
+          <a:fillRef idx="3">
+            <a:schemeClr val="accent1"/>
+          </a:fillRef>
+          <a:effectRef idx="2">
+            <a:schemeClr val="accent1"/>
+          </a:effectRef>
+          <a:fontRef idx="minor">
+            <a:schemeClr val="lt1"/>
+          </a:fontRef>
+        </p:style>
+        <p:txBody>
+          <a:bodyPr rtlCol="0" anchor="ctr" wrap="square" lIns="274320" rIns="274320" tIns="182880" bIns="182880"/>
+          <a:lstStyle/>
+          <a:p>
+            <a:pPr algn="l">
+              <a:spcAft>
+                <a:spcPts val="200"/>
+              </a:spcAft>
+              <a:defRPr sz="1300">
+                <a:solidFill>
+                  <a:srgbClr val="A6E3A1"/>
+                </a:solidFill>
+                <a:latin typeface="JetBrains Mono"/>
+              </a:defRPr>
+            </a:pPr>
+            <a:r>
+              <a:t>npx ccstatusline@latest</a:t>
+            </a:r>
+          </a:p>
+        </p:txBody>
+      </p:sp>
+      <p:sp>
+        <p:nvSpPr>
+          <p:cNvPr id="8" name="TextBox 7"/>
+          <p:cNvSpPr txBox="1"/>
+          <p:nvPr/>
+        </p:nvSpPr>
+        <p:spPr>
+          <a:xfrm>
+            <a:off x="731520" y="3566160"/>
+            <a:ext cx="10058400" cy="457200"/>
+          </a:xfrm>
+          <a:prstGeom prst="rect">
+            <a:avLst/>
+          </a:prstGeom>
+          <a:noFill/>
+        </p:spPr>
+        <p:txBody>
+          <a:bodyPr wrap="square">
+            <a:spAutoFit/>
+          </a:bodyPr>
+          <a:lstStyle/>
+          <a:p>
+            <a:pPr algn="l">
+              <a:defRPr sz="2200" b="1">
+                <a:solidFill>
+                  <a:srgbClr val="CBA6F7"/>
+                </a:solidFill>
+                <a:latin typeface="JetBrains Mono"/>
+              </a:defRPr>
+            </a:pPr>
+            <a:r>
+              <a:t>Superpowers (Plugin)</a:t>
+            </a:r>
+          </a:p>
+        </p:txBody>
+      </p:sp>
+      <p:sp>
+        <p:nvSpPr>
+          <p:cNvPr id="9" name="TextBox 8"/>
+          <p:cNvSpPr txBox="1"/>
+          <p:nvPr/>
+        </p:nvSpPr>
+        <p:spPr>
+          <a:xfrm>
+            <a:off x="731520" y="4114800"/>
+            <a:ext cx="10058400" cy="1371600"/>
+          </a:xfrm>
+          <a:prstGeom prst="rect">
+            <a:avLst/>
+          </a:prstGeom>
+          <a:noFill/>
+        </p:spPr>
+        <p:txBody>
+          <a:bodyPr wrap="square">
+            <a:spAutoFit/>
+          </a:bodyPr>
+          <a:lstStyle/>
+          <a:p>
+            <a:pPr>
+              <a:spcAft>
+                <a:spcPts val="600"/>
+              </a:spcAft>
+            </a:pPr>
+            <a:r>
+              <a:rPr sz="1500" b="1">
+                <a:solidFill>
+                  <a:srgbClr val="CBA6F7"/>
+                </a:solidFill>
+                <a:latin typeface="JetBrains Mono"/>
+              </a:rPr>
+              <a:t>• </a:t>
+            </a:r>
+            <a:r>
+              <a:rPr sz="1500">
+                <a:solidFill>
+                  <a:srgbClr val="CDD6F4"/>
+                </a:solidFill>
+                <a:latin typeface="JetBrains Mono"/>
+              </a:rPr>
+              <a:t>Orchestration layer dispatching sub-agents in their own context</a:t>
+            </a:r>
+          </a:p>
+          <a:p>
+            <a:pPr>
+              <a:spcAft>
+                <a:spcPts val="600"/>
+              </a:spcAft>
+            </a:pPr>
+            <a:r>
+              <a:rPr sz="1500" b="1">
+                <a:solidFill>
+                  <a:srgbClr val="CBA6F7"/>
+                </a:solidFill>
+                <a:latin typeface="JetBrains Mono"/>
+              </a:rPr>
+              <a:t>• </a:t>
+            </a:r>
+            <a:r>
+              <a:rPr sz="1500">
+                <a:solidFill>
+                  <a:srgbClr val="CDD6F4"/>
+                </a:solidFill>
+                <a:latin typeface="JetBrains Mono"/>
+              </a:rPr>
+              <a:t>Prevents context poisoning in your main session</a:t>
+            </a:r>
+          </a:p>
+          <a:p>
+            <a:pPr>
+              <a:spcAft>
+                <a:spcPts val="600"/>
+              </a:spcAft>
+            </a:pPr>
+            <a:r>
+              <a:rPr sz="1500" b="1">
+                <a:solidFill>
+                  <a:srgbClr val="CBA6F7"/>
+                </a:solidFill>
+                <a:latin typeface="JetBrains Mono"/>
+              </a:rPr>
+              <a:t>• </a:t>
+            </a:r>
+            <a:r>
+              <a:rPr sz="1500">
+                <a:solidFill>
+                  <a:srgbClr val="CDD6F4"/>
+                </a:solidFill>
+                <a:latin typeface="JetBrains Mono"/>
+              </a:rPr>
+              <a:t>Core: /brainstorming → /writing-plans → /executing-plans</a:t>
+            </a:r>
+          </a:p>
+        </p:txBody>
+      </p:sp>
+      <p:sp>
+        <p:nvSpPr>
+          <p:cNvPr id="10" name="Rounded Rectangle 9"/>
+          <p:cNvSpPr/>
+          <p:nvPr/>
+        </p:nvSpPr>
+        <p:spPr>
+          <a:xfrm>
+            <a:off x="731520" y="5669280"/>
+            <a:ext cx="7315200" cy="548640"/>
+          </a:xfrm>
+          <a:prstGeom prst="roundRect">
+            <a:avLst/>
+          </a:prstGeom>
+          <a:solidFill>
+            <a:srgbClr val="181825"/>
+          </a:solidFill>
+          <a:ln>
+            <a:noFill/>
+          </a:ln>
+          <a:effectLst/>
+        </p:spPr>
+        <p:style>
+          <a:lnRef idx="1">
+            <a:schemeClr val="accent1"/>
+          </a:lnRef>
+          <a:fillRef idx="3">
+            <a:schemeClr val="accent1"/>
+          </a:fillRef>
+          <a:effectRef idx="2">
+            <a:schemeClr val="accent1"/>
+          </a:effectRef>
+          <a:fontRef idx="minor">
+            <a:schemeClr val="lt1"/>
+          </a:fontRef>
+        </p:style>
+        <p:txBody>
+          <a:bodyPr rtlCol="0" anchor="ctr" wrap="square" lIns="274320" rIns="274320" tIns="182880" bIns="182880"/>
+          <a:lstStyle/>
+          <a:p>
+            <a:pPr algn="l">
+              <a:spcAft>
+                <a:spcPts val="200"/>
+              </a:spcAft>
+              <a:defRPr sz="1300">
+                <a:solidFill>
+                  <a:srgbClr val="A6E3A1"/>
+                </a:solidFill>
+                <a:latin typeface="JetBrains Mono"/>
+              </a:defRPr>
+            </a:pPr>
+            <a:r>
+              <a:t>/plugin install superpowers@claude-plugins-official</a:t>
+            </a:r>
+          </a:p>
+        </p:txBody>
+      </p:sp>
+    </p:spTree>
+  </p:cSld>
+  <p:clrMapOvr>
+    <a:masterClrMapping/>
+  </p:clrMapOvr>
+</p:sld>
+</file>
+
+<file path=ppt/slides/slide48.xml><?xml version="1.0" encoding="utf-8"?>
+<p:sld xmlns:a="http://schemas.openxmlformats.org/drawingml/2006/main" xmlns:p="http://schemas.openxmlformats.org/presentationml/2006/main" xmlns:r="http://schemas.openxmlformats.org/officeDocument/2006/relationships">
+  <p:cSld>
+    <p:bg>
+      <p:bgPr>
+        <a:solidFill>
+          <a:srgbClr val="1E1E2E"/>
+        </a:solidFill>
+        <a:effectLst/>
+      </p:bgPr>
+    </p:bg>
+    <p:spTree>
+      <p:nvGrpSpPr>
+        <p:cNvPr id="1" name=""/>
+        <p:cNvGrpSpPr/>
+        <p:nvPr/>
+      </p:nvGrpSpPr>
+      <p:grpSpPr/>
+      <p:sp>
+        <p:nvSpPr>
+          <p:cNvPr id="2" name="Rectangle 1"/>
+          <p:cNvSpPr/>
+          <p:nvPr/>
+        </p:nvSpPr>
+        <p:spPr>
+          <a:xfrm>
+            <a:off x="0" y="0"/>
+            <a:ext cx="73152" cy="6858000"/>
+          </a:xfrm>
+          <a:prstGeom prst="rect">
+            <a:avLst/>
+          </a:prstGeom>
+          <a:solidFill>
+            <a:srgbClr val="F2CDCD"/>
+          </a:solidFill>
+          <a:ln>
+            <a:noFill/>
+          </a:ln>
+        </p:spPr>
+        <p:style>
+          <a:lnRef idx="1">
+            <a:schemeClr val="accent1"/>
+          </a:lnRef>
+          <a:fillRef idx="3">
+            <a:schemeClr val="accent1"/>
+          </a:fillRef>
+          <a:effectRef idx="2">
+            <a:schemeClr val="accent1"/>
+          </a:effectRef>
+          <a:fontRef idx="minor">
+            <a:schemeClr val="lt1"/>
+          </a:fontRef>
+        </p:style>
+        <p:txBody>
+          <a:bodyPr rtlCol="0" anchor="ctr"/>
+          <a:lstStyle/>
+          <a:p>
+            <a:pPr algn="ctr"/>
+          </a:p>
+        </p:txBody>
+      </p:sp>
+      <p:sp>
+        <p:nvSpPr>
+          <p:cNvPr id="3" name="TextBox 2"/>
+          <p:cNvSpPr txBox="1"/>
+          <p:nvPr/>
+        </p:nvSpPr>
+        <p:spPr>
+          <a:xfrm>
+            <a:off x="548640" y="274320"/>
+            <a:ext cx="9144000" cy="640080"/>
+          </a:xfrm>
+          <a:prstGeom prst="rect">
+            <a:avLst/>
+          </a:prstGeom>
+          <a:noFill/>
+        </p:spPr>
+        <p:txBody>
+          <a:bodyPr wrap="square">
+            <a:spAutoFit/>
+          </a:bodyPr>
+          <a:lstStyle/>
+          <a:p>
+            <a:pPr algn="l">
+              <a:defRPr sz="2800" b="1">
+                <a:solidFill>
+                  <a:srgbClr val="CDD6F4"/>
+                </a:solidFill>
+                <a:latin typeface="JetBrains Mono"/>
+              </a:defRPr>
+            </a:pPr>
+            <a:r>
+              <a:t>Recommended Tools &amp; Plugins (cont.)</a:t>
+            </a:r>
+          </a:p>
+        </p:txBody>
+      </p:sp>
+      <p:sp>
+        <p:nvSpPr>
+          <p:cNvPr id="4" name="Rectangle 3"/>
+          <p:cNvSpPr/>
+          <p:nvPr/>
+        </p:nvSpPr>
+        <p:spPr>
+          <a:xfrm>
+            <a:off x="548640" y="960120"/>
+            <a:ext cx="2743200" cy="36576"/>
+          </a:xfrm>
+          <a:prstGeom prst="rect">
+            <a:avLst/>
+          </a:prstGeom>
+          <a:solidFill>
+            <a:srgbClr val="F2CDCD"/>
+          </a:solidFill>
+          <a:ln>
+            <a:noFill/>
+          </a:ln>
+        </p:spPr>
+        <p:style>
+          <a:lnRef idx="1">
+            <a:schemeClr val="accent1"/>
+          </a:lnRef>
+          <a:fillRef idx="3">
+            <a:schemeClr val="accent1"/>
+          </a:fillRef>
+          <a:effectRef idx="2">
+            <a:schemeClr val="accent1"/>
+          </a:effectRef>
+          <a:fontRef idx="minor">
+            <a:schemeClr val="lt1"/>
+          </a:fontRef>
+        </p:style>
+        <p:txBody>
+          <a:bodyPr rtlCol="0" anchor="ctr"/>
+          <a:lstStyle/>
+          <a:p>
+            <a:pPr algn="ctr"/>
+          </a:p>
+        </p:txBody>
+      </p:sp>
+      <p:sp>
+        <p:nvSpPr>
+          <p:cNvPr id="5" name="TextBox 4"/>
+          <p:cNvSpPr txBox="1"/>
+          <p:nvPr/>
+        </p:nvSpPr>
+        <p:spPr>
+          <a:xfrm>
+            <a:off x="731520" y="1188720"/>
+            <a:ext cx="10058400" cy="457200"/>
+          </a:xfrm>
+          <a:prstGeom prst="rect">
+            <a:avLst/>
+          </a:prstGeom>
+          <a:noFill/>
+        </p:spPr>
+        <p:txBody>
+          <a:bodyPr wrap="square">
+            <a:spAutoFit/>
+          </a:bodyPr>
+          <a:lstStyle/>
+          <a:p>
+            <a:pPr algn="l">
+              <a:defRPr sz="2000" b="1">
+                <a:solidFill>
+                  <a:srgbClr val="B4BEFE"/>
+                </a:solidFill>
+                <a:latin typeface="JetBrains Mono"/>
+              </a:defRPr>
+            </a:pPr>
+            <a:r>
+              <a:t>Code Simplifier (Plugin)</a:t>
+            </a:r>
+          </a:p>
+        </p:txBody>
+      </p:sp>
+      <p:sp>
+        <p:nvSpPr>
+          <p:cNvPr id="6" name="TextBox 5"/>
+          <p:cNvSpPr txBox="1"/>
+          <p:nvPr/>
+        </p:nvSpPr>
+        <p:spPr>
+          <a:xfrm>
+            <a:off x="731520" y="1691640"/>
+            <a:ext cx="10058400" cy="548640"/>
+          </a:xfrm>
+          <a:prstGeom prst="rect">
+            <a:avLst/>
+          </a:prstGeom>
+          <a:noFill/>
+        </p:spPr>
+        <p:txBody>
+          <a:bodyPr wrap="square">
+            <a:spAutoFit/>
+          </a:bodyPr>
+          <a:lstStyle/>
+          <a:p>
+            <a:pPr>
+              <a:spcAft>
+                <a:spcPts val="400"/>
+              </a:spcAft>
+            </a:pPr>
+            <a:r>
+              <a:rPr sz="1500" b="1">
+                <a:solidFill>
+                  <a:srgbClr val="B4BEFE"/>
+                </a:solidFill>
+                <a:latin typeface="JetBrains Mono"/>
+              </a:rPr>
+              <a:t>• </a:t>
+            </a:r>
+            <a:r>
+              <a:rPr sz="1500">
+                <a:solidFill>
+                  <a:srgbClr val="CDD6F4"/>
+                </a:solidFill>
+                <a:latin typeface="JetBrains Mono"/>
+              </a:rPr>
+              <a:t>Reviews changed code for reuse, quality, and efficiency, then fixes issues</a:t>
+            </a:r>
+          </a:p>
+        </p:txBody>
+      </p:sp>
+      <p:sp>
+        <p:nvSpPr>
+          <p:cNvPr id="7" name="Rounded Rectangle 6"/>
+          <p:cNvSpPr/>
+          <p:nvPr/>
+        </p:nvSpPr>
+        <p:spPr>
+          <a:xfrm>
+            <a:off x="731520" y="2286000"/>
+            <a:ext cx="7315200" cy="548640"/>
+          </a:xfrm>
+          <a:prstGeom prst="roundRect">
+            <a:avLst/>
+          </a:prstGeom>
+          <a:solidFill>
+            <a:srgbClr val="181825"/>
+          </a:solidFill>
+          <a:ln>
+            <a:noFill/>
+          </a:ln>
+          <a:effectLst/>
+        </p:spPr>
+        <p:style>
+          <a:lnRef idx="1">
+            <a:schemeClr val="accent1"/>
+          </a:lnRef>
+          <a:fillRef idx="3">
+            <a:schemeClr val="accent1"/>
+          </a:fillRef>
+          <a:effectRef idx="2">
+            <a:schemeClr val="accent1"/>
+          </a:effectRef>
+          <a:fontRef idx="minor">
+            <a:schemeClr val="lt1"/>
+          </a:fontRef>
+        </p:style>
+        <p:txBody>
+          <a:bodyPr rtlCol="0" anchor="ctr" wrap="square" lIns="274320" rIns="274320" tIns="182880" bIns="182880"/>
+          <a:lstStyle/>
+          <a:p>
+            <a:pPr algn="l">
+              <a:spcAft>
+                <a:spcPts val="200"/>
+              </a:spcAft>
+              <a:defRPr sz="1300">
+                <a:solidFill>
+                  <a:srgbClr val="A6E3A1"/>
+                </a:solidFill>
+                <a:latin typeface="JetBrains Mono"/>
+              </a:defRPr>
+            </a:pPr>
+            <a:r>
+              <a:t>/plugin  →  search 'code simplifier'  →  install</a:t>
+            </a:r>
+          </a:p>
+        </p:txBody>
+      </p:sp>
+      <p:sp>
+        <p:nvSpPr>
+          <p:cNvPr id="8" name="TextBox 7"/>
+          <p:cNvSpPr txBox="1"/>
+          <p:nvPr/>
+        </p:nvSpPr>
+        <p:spPr>
+          <a:xfrm>
+            <a:off x="731520" y="3108960"/>
+            <a:ext cx="10058400" cy="457200"/>
+          </a:xfrm>
+          <a:prstGeom prst="rect">
+            <a:avLst/>
+          </a:prstGeom>
+          <a:noFill/>
+        </p:spPr>
+        <p:txBody>
+          <a:bodyPr wrap="square">
+            <a:spAutoFit/>
+          </a:bodyPr>
+          <a:lstStyle/>
+          <a:p>
+            <a:pPr algn="l">
+              <a:defRPr sz="2000" b="1">
+                <a:solidFill>
+                  <a:srgbClr val="FAB387"/>
+                </a:solidFill>
+                <a:latin typeface="JetBrains Mono"/>
+              </a:defRPr>
+            </a:pPr>
+            <a:r>
+              <a:t>Sequential Thinking (MCP Server)</a:t>
+            </a:r>
+          </a:p>
+        </p:txBody>
+      </p:sp>
+      <p:sp>
+        <p:nvSpPr>
+          <p:cNvPr id="9" name="TextBox 8"/>
+          <p:cNvSpPr txBox="1"/>
+          <p:nvPr/>
+        </p:nvSpPr>
+        <p:spPr>
+          <a:xfrm>
+            <a:off x="731520" y="3611880"/>
+            <a:ext cx="10058400" cy="548640"/>
+          </a:xfrm>
+          <a:prstGeom prst="rect">
+            <a:avLst/>
+          </a:prstGeom>
+          <a:noFill/>
+        </p:spPr>
+        <p:txBody>
+          <a:bodyPr wrap="square">
+            <a:spAutoFit/>
+          </a:bodyPr>
+          <a:lstStyle/>
+          <a:p>
+            <a:pPr>
+              <a:spcAft>
+                <a:spcPts val="400"/>
+              </a:spcAft>
+            </a:pPr>
+            <a:r>
+              <a:rPr sz="1500" b="1">
+                <a:solidFill>
+                  <a:srgbClr val="FAB387"/>
+                </a:solidFill>
+                <a:latin typeface="JetBrains Mono"/>
+              </a:rPr>
+              <a:t>• </a:t>
+            </a:r>
+            <a:r>
+              <a:rPr sz="1500">
+                <a:solidFill>
+                  <a:srgbClr val="CDD6F4"/>
+                </a:solidFill>
+                <a:latin typeface="JetBrains Mono"/>
+              </a:rPr>
+              <a:t>Chain-of-thought reasoning for deeper analysis during brainstorming and planning</a:t>
+            </a:r>
+          </a:p>
+        </p:txBody>
+      </p:sp>
+      <p:sp>
+        <p:nvSpPr>
+          <p:cNvPr id="10" name="Rounded Rectangle 9"/>
+          <p:cNvSpPr/>
+          <p:nvPr/>
+        </p:nvSpPr>
+        <p:spPr>
+          <a:xfrm>
+            <a:off x="731520" y="4206240"/>
+            <a:ext cx="7315200" cy="548640"/>
+          </a:xfrm>
+          <a:prstGeom prst="roundRect">
+            <a:avLst/>
+          </a:prstGeom>
+          <a:solidFill>
+            <a:srgbClr val="181825"/>
+          </a:solidFill>
+          <a:ln>
+            <a:noFill/>
+          </a:ln>
+          <a:effectLst/>
+        </p:spPr>
+        <p:style>
+          <a:lnRef idx="1">
+            <a:schemeClr val="accent1"/>
+          </a:lnRef>
+          <a:fillRef idx="3">
+            <a:schemeClr val="accent1"/>
+          </a:fillRef>
+          <a:effectRef idx="2">
+            <a:schemeClr val="accent1"/>
+          </a:effectRef>
+          <a:fontRef idx="minor">
+            <a:schemeClr val="lt1"/>
+          </a:fontRef>
+        </p:style>
+        <p:txBody>
+          <a:bodyPr rtlCol="0" anchor="ctr" wrap="square" lIns="274320" rIns="274320" tIns="182880" bIns="182880"/>
+          <a:lstStyle/>
+          <a:p>
+            <a:pPr algn="l">
+              <a:spcAft>
+                <a:spcPts val="200"/>
+              </a:spcAft>
+              <a:defRPr sz="1300">
+                <a:solidFill>
+                  <a:srgbClr val="A6E3A1"/>
+                </a:solidFill>
+                <a:latin typeface="JetBrains Mono"/>
+              </a:defRPr>
+            </a:pPr>
+            <a:r>
+              <a:t>Tell Claude: 'please install sequential thinking MCP server'</a:t>
+            </a:r>
+          </a:p>
+        </p:txBody>
+      </p:sp>
+      <p:sp>
+        <p:nvSpPr>
+          <p:cNvPr id="11" name="TextBox 10"/>
+          <p:cNvSpPr txBox="1"/>
+          <p:nvPr/>
+        </p:nvSpPr>
+        <p:spPr>
+          <a:xfrm>
+            <a:off x="731520" y="5029200"/>
+            <a:ext cx="10058400" cy="457200"/>
+          </a:xfrm>
+          <a:prstGeom prst="rect">
+            <a:avLst/>
+          </a:prstGeom>
+          <a:noFill/>
+        </p:spPr>
+        <p:txBody>
+          <a:bodyPr wrap="square">
+            <a:spAutoFit/>
+          </a:bodyPr>
+          <a:lstStyle/>
+          <a:p>
+            <a:pPr algn="l">
+              <a:defRPr sz="2000" b="1">
+                <a:solidFill>
+                  <a:srgbClr val="89DCEB"/>
+                </a:solidFill>
+                <a:latin typeface="JetBrains Mono"/>
+              </a:defRPr>
+            </a:pPr>
+            <a:r>
+              <a:t>Context7 (Plugin)</a:t>
+            </a:r>
+          </a:p>
+        </p:txBody>
+      </p:sp>
+      <p:sp>
+        <p:nvSpPr>
+          <p:cNvPr id="12" name="TextBox 11"/>
+          <p:cNvSpPr txBox="1"/>
+          <p:nvPr/>
+        </p:nvSpPr>
+        <p:spPr>
+          <a:xfrm>
+            <a:off x="731520" y="5532120"/>
+            <a:ext cx="10058400" cy="548640"/>
+          </a:xfrm>
+          <a:prstGeom prst="rect">
+            <a:avLst/>
+          </a:prstGeom>
+          <a:noFill/>
+        </p:spPr>
+        <p:txBody>
+          <a:bodyPr wrap="square">
+            <a:spAutoFit/>
+          </a:bodyPr>
+          <a:lstStyle/>
+          <a:p>
+            <a:pPr>
+              <a:spcAft>
+                <a:spcPts val="400"/>
+              </a:spcAft>
+            </a:pPr>
+            <a:r>
+              <a:rPr sz="1500" b="1">
+                <a:solidFill>
+                  <a:srgbClr val="89DCEB"/>
+                </a:solidFill>
+                <a:latin typeface="JetBrains Mono"/>
+              </a:rPr>
+              <a:t>• </a:t>
+            </a:r>
+            <a:r>
+              <a:rPr sz="1500">
+                <a:solidFill>
+                  <a:srgbClr val="CDD6F4"/>
+                </a:solidFill>
+                <a:latin typeface="JetBrains Mono"/>
+              </a:rPr>
+              <a:t>Up-to-date API/library docs — fixes hallucinated outdated APIs</a:t>
+            </a:r>
+          </a:p>
+        </p:txBody>
+      </p:sp>
+      <p:sp>
+        <p:nvSpPr>
+          <p:cNvPr id="13" name="Rounded Rectangle 12"/>
+          <p:cNvSpPr/>
+          <p:nvPr/>
+        </p:nvSpPr>
+        <p:spPr>
+          <a:xfrm>
+            <a:off x="731520" y="6126480"/>
+            <a:ext cx="7315200" cy="548640"/>
+          </a:xfrm>
+          <a:prstGeom prst="roundRect">
+            <a:avLst/>
+          </a:prstGeom>
+          <a:solidFill>
+            <a:srgbClr val="181825"/>
+          </a:solidFill>
+          <a:ln>
+            <a:noFill/>
+          </a:ln>
+          <a:effectLst/>
+        </p:spPr>
+        <p:style>
+          <a:lnRef idx="1">
+            <a:schemeClr val="accent1"/>
+          </a:lnRef>
+          <a:fillRef idx="3">
+            <a:schemeClr val="accent1"/>
+          </a:fillRef>
+          <a:effectRef idx="2">
+            <a:schemeClr val="accent1"/>
+          </a:effectRef>
+          <a:fontRef idx="minor">
+            <a:schemeClr val="lt1"/>
+          </a:fontRef>
+        </p:style>
+        <p:txBody>
+          <a:bodyPr rtlCol="0" anchor="ctr" wrap="square" lIns="274320" rIns="274320" tIns="182880" bIns="182880"/>
+          <a:lstStyle/>
+          <a:p>
+            <a:pPr algn="l">
+              <a:spcAft>
+                <a:spcPts val="200"/>
+              </a:spcAft>
+              <a:defRPr sz="1300">
+                <a:solidFill>
+                  <a:srgbClr val="A6E3A1"/>
+                </a:solidFill>
+                <a:latin typeface="JetBrains Mono"/>
+              </a:defRPr>
+            </a:pPr>
+            <a:r>
+              <a:t>/plugin  →  search 'context7'  →  install</a:t>
+            </a:r>
+          </a:p>
+        </p:txBody>
+      </p:sp>
+    </p:spTree>
+  </p:cSld>
+  <p:clrMapOvr>
+    <a:masterClrMapping/>
+  </p:clrMapOvr>
+</p:sld>
+</file>
+
+<file path=ppt/slides/slide49.xml><?xml version="1.0" encoding="utf-8"?>
 <p:sld xmlns:a="http://schemas.openxmlformats.org/drawingml/2006/main" xmlns:p="http://schemas.openxmlformats.org/presentationml/2006/main" xmlns:r="http://schemas.openxmlformats.org/officeDocument/2006/relationships">
   <p:cSld>
     <p:bg>
@@ -18054,6 +19247,31 @@
                 <a:latin typeface="JetBrains Mono"/>
               </a:rPr>
               <a:t>A code editor (VS Code / Cursor / terminal)</a:t>
+            </a:r>
+          </a:p>
+          <a:p>
+            <a:pPr>
+              <a:spcAft>
+                <a:spcPts val="1800"/>
+              </a:spcAft>
+            </a:pPr>
+            <a:r>
+              <a:rPr sz="2000" b="1">
+                <a:solidFill>
+                  <a:srgbClr val="A6E3A1"/>
+                </a:solidFill>
+                <a:latin typeface="JetBrains Mono"/>
+              </a:rPr>
+              <a:t>✓ </a:t>
+            </a:r>
+            <a:r>
+              <a:rPr sz="2000">
+                <a:solidFill>
+                  <a:srgbClr val="CDD6F4"/>
+                </a:solidFill>
+                <a:latin typeface="JetBrains Mono"/>
+              </a:rPr>
+              <a:t>Running /install command in CC checks and installs required tools</a:t>
             </a:r>
           </a:p>
         </p:txBody>

</xml_diff>

<commit_message>
chore: update training presentation slides
Generated with [Claude Code](https://claude.com/claude-code)

Co-Authored-By: Claude Opus 4.5 <noreply@anthropic.com>
</commit_message>
<xml_diff>
--- a/claude-code-advanced-training.pptx
+++ b/claude-code-advanced-training.pptx
@@ -17665,7 +17665,7 @@
                 </a:solidFill>
                 <a:latin typeface="JetBrains Mono"/>
               </a:rPr>
-              <a:t>Tactical Agentic Coding: agenticengineer.com/tactical-agentic-coding</a:t>
+              <a:t>Tactical Agentic Coding: https://agenticengineer.com/tactical-agentic-coding</a:t>
             </a:r>
           </a:p>
           <a:p>
@@ -17691,31 +17691,6 @@
                 <a:latin typeface="JetBrains Mono"/>
               </a:rPr>
               <a:t>Practical patterns for working effectively with AI coding agents</a:t>
-            </a:r>
-          </a:p>
-          <a:p>
-            <a:pPr>
-              <a:spcAft>
-                <a:spcPts val="1800"/>
-              </a:spcAft>
-            </a:pPr>
-            <a:r>
-              <a:rPr sz="1800" b="1">
-                <a:solidFill>
-                  <a:srgbClr val="F2CDCD"/>
-                </a:solidFill>
-                <a:latin typeface="JetBrains Mono"/>
-              </a:rPr>
-              <a:t>• </a:t>
-            </a:r>
-            <a:r>
-              <a:rPr sz="1800">
-                <a:solidFill>
-                  <a:srgbClr val="CDD6F4"/>
-                </a:solidFill>
-                <a:latin typeface="JetBrains Mono"/>
-              </a:rPr>
-              <a:t>Feedback &amp; issues: github.com/anthropics/claude-code/issues</a:t>
             </a:r>
           </a:p>
         </p:txBody>

</xml_diff>